<commit_message>
Xatolarni tuzatish: ishga tushirish, qayta import va matndagi noaniqliklar
main.py PyCharm namunasi edi — Ishga_tushirish.bat saytni ochmasdi; asl ishga tushiruvchi qaytarildi,
birinchi ishga tushishda materiallar, videolar va taqdimotlar ham tayyorlanadi.
Qayta import: videolar, taqdimotlar va yuklangan fayllar mavzular bilan o'chib ketmaydi (mavzu raqami
bo'yicha qayta bog'lanadi); glossariyda eski ta'riflar mavzusiz qolib ketmaydi. materiallar buyrug'i
ma'ruzalar Word faylini har safar yangilaydi.
Matn: rus tilidagi Excel'da ЕСЛИ, Windows'da «Администраторы» guruhi, 7-Zip ochiq kodli, fayl nomini
shifrlash faqat 7z formatida; 2 ta testdagi noaniq variantlar almashtirildi.

Co-Authored-By: Claude Opus 5.5 <noreply@anthropic.com>
</commit_message>
<xml_diff>
--- a/sayt/media/resources/2026/10/axborot-xavfsizligi-13-mavzu.pptx
+++ b/sayt/media/resources/2026/10/axborot-xavfsizligi-13-mavzu.pptx
@@ -12640,7 +12640,7 @@
         <p:spPr>
           <a:xfrm>
             <a:off x="731520" y="1608582"/>
-            <a:ext cx="45720" cy="436372"/>
+            <a:ext cx="45720" cy="419862"/>
           </a:xfrm>
           <a:prstGeom prst="rect">
             <a:avLst/>
@@ -12684,7 +12684,7 @@
         <p:spPr>
           <a:xfrm>
             <a:off x="960120" y="1645158"/>
-            <a:ext cx="10920057" cy="408940"/>
+            <a:ext cx="10920057" cy="392430"/>
           </a:xfrm>
           <a:prstGeom prst="rect">
             <a:avLst/>
@@ -12699,11 +12699,11 @@
           <a:p>
             <a:pPr algn="l">
               <a:lnSpc>
-                <a:spcPts val="2860"/>
+                <a:spcPts val="2730"/>
               </a:lnSpc>
             </a:pPr>
             <a:r>
-              <a:rPr sz="2200" b="0">
+              <a:rPr sz="2100" b="0">
                 <a:solidFill>
                   <a:srgbClr val="3A4560"/>
                 </a:solidFill>
@@ -12722,7 +12722,7 @@
         </p:nvSpPr>
         <p:spPr>
           <a:xfrm rot="2700000">
-            <a:off x="841161" y="2319949"/>
+            <a:off x="841161" y="2295565"/>
             <a:ext cx="109901" cy="109901"/>
           </a:xfrm>
           <a:prstGeom prst="rect">
@@ -12766,8 +12766,8 @@
         </p:nvSpPr>
         <p:spPr>
           <a:xfrm>
-            <a:off x="1143000" y="2209546"/>
-            <a:ext cx="10729862" cy="728472"/>
+            <a:off x="1143000" y="2193036"/>
+            <a:ext cx="10729862" cy="695960"/>
           </a:xfrm>
           <a:prstGeom prst="rect">
             <a:avLst/>
@@ -12782,11 +12782,11 @@
           <a:p>
             <a:pPr algn="l">
               <a:lnSpc>
-                <a:spcPts val="2688"/>
+                <a:spcPts val="2560"/>
               </a:lnSpc>
             </a:pPr>
             <a:r>
-              <a:rPr sz="2100" b="1">
+              <a:rPr sz="2000" b="1">
                 <a:solidFill>
                   <a:srgbClr val="1B2A4A"/>
                 </a:solidFill>
@@ -12795,23 +12795,23 @@
               <a:t>Jadval tuzish.: </a:t>
             </a:r>
             <a:r>
-              <a:rPr sz="2100" b="0">
+              <a:rPr sz="2000" b="0">
                 <a:solidFill>
                   <a:srgbClr val="1B2A4A"/>
                 </a:solidFill>
                 <a:latin typeface="Segoe UI"/>
               </a:rPr>
-              <a:t>Excel’da ustunlar yarating: A — №, B — Tahdid, C — Ehtimollik, D —</a:t>
+              <a:t>Excel’da ustunlar yarating: A — №, B — Tahdid, C — Ehtimollik, D — Zarar, E</a:t>
             </a:r>
             <a:br/>
             <a:r>
-              <a:rPr sz="2100" b="0">
+              <a:rPr sz="2000" b="0">
                 <a:solidFill>
                   <a:srgbClr val="1B2A4A"/>
                 </a:solidFill>
                 <a:latin typeface="Segoe UI"/>
               </a:rPr>
-              <a:t>Zarar, E — Xavf darajasi, F — Chora.</a:t>
+              <a:t>— Xavf darajasi, F — Chora.</a:t>
             </a:r>
           </a:p>
         </p:txBody>
@@ -12824,7 +12824,7 @@
         </p:nvSpPr>
         <p:spPr>
           <a:xfrm rot="2700000">
-            <a:off x="841161" y="3149005"/>
+            <a:off x="841161" y="3092109"/>
             <a:ext cx="109901" cy="109901"/>
           </a:xfrm>
           <a:prstGeom prst="rect">
@@ -12868,8 +12868,8 @@
         </p:nvSpPr>
         <p:spPr>
           <a:xfrm>
-            <a:off x="1143000" y="3038602"/>
-            <a:ext cx="10729862" cy="728472"/>
+            <a:off x="1143000" y="2989580"/>
+            <a:ext cx="10729862" cy="695960"/>
           </a:xfrm>
           <a:prstGeom prst="rect">
             <a:avLst/>
@@ -12884,11 +12884,11 @@
           <a:p>
             <a:pPr algn="l">
               <a:lnSpc>
-                <a:spcPts val="2688"/>
+                <a:spcPts val="2560"/>
               </a:lnSpc>
             </a:pPr>
             <a:r>
-              <a:rPr sz="2100" b="1">
+              <a:rPr sz="2000" b="1">
                 <a:solidFill>
                   <a:srgbClr val="1B2A4A"/>
                 </a:solidFill>
@@ -12897,23 +12897,23 @@
               <a:t>Ma’lumot kiritish.: </a:t>
             </a:r>
             <a:r>
-              <a:rPr sz="2100" b="0">
+              <a:rPr sz="2000" b="0">
                 <a:solidFill>
                   <a:srgbClr val="1B2A4A"/>
                 </a:solidFill>
                 <a:latin typeface="Segoe UI"/>
               </a:rPr>
-              <a:t>Xavflar reyestridagi kamida 8 ta tahdidni kiriting va har biriga 1–3</a:t>
+              <a:t>Xavflar reyestridagi kamida 8 ta tahdidni kiriting va har biriga 1–3 ball</a:t>
             </a:r>
             <a:br/>
             <a:r>
-              <a:rPr sz="2100" b="0">
+              <a:rPr sz="2000" b="0">
                 <a:solidFill>
                   <a:srgbClr val="1B2A4A"/>
                 </a:solidFill>
                 <a:latin typeface="Segoe UI"/>
               </a:rPr>
-              <a:t>ball qo‘ying.</a:t>
+              <a:t>qo‘ying.</a:t>
             </a:r>
           </a:p>
         </p:txBody>
@@ -12926,7 +12926,7 @@
         </p:nvSpPr>
         <p:spPr>
           <a:xfrm rot="2700000">
-            <a:off x="841161" y="3978061"/>
+            <a:off x="841161" y="3888653"/>
             <a:ext cx="109901" cy="109901"/>
           </a:xfrm>
           <a:prstGeom prst="rect">
@@ -12970,8 +12970,8 @@
         </p:nvSpPr>
         <p:spPr>
           <a:xfrm>
-            <a:off x="1143000" y="3867658"/>
-            <a:ext cx="10729862" cy="387095"/>
+            <a:off x="1143000" y="3786124"/>
+            <a:ext cx="10729862" cy="370840"/>
           </a:xfrm>
           <a:prstGeom prst="rect">
             <a:avLst/>
@@ -12986,11 +12986,11 @@
           <a:p>
             <a:pPr algn="l">
               <a:lnSpc>
-                <a:spcPts val="2688"/>
+                <a:spcPts val="2560"/>
               </a:lnSpc>
             </a:pPr>
             <a:r>
-              <a:rPr sz="2100" b="1">
+              <a:rPr sz="2000" b="1">
                 <a:solidFill>
                   <a:srgbClr val="1B2A4A"/>
                 </a:solidFill>
@@ -12999,7 +12999,7 @@
               <a:t>Formula yozish.: </a:t>
             </a:r>
             <a:r>
-              <a:rPr sz="2100" b="0">
+              <a:rPr sz="2000" b="0">
                 <a:solidFill>
                   <a:srgbClr val="1B2A4A"/>
                 </a:solidFill>
@@ -13018,7 +13018,7 @@
         </p:nvSpPr>
         <p:spPr>
           <a:xfrm rot="2700000">
-            <a:off x="841161" y="4465741"/>
+            <a:off x="841161" y="4360077"/>
             <a:ext cx="109901" cy="109901"/>
           </a:xfrm>
           <a:prstGeom prst="rect">
@@ -13062,8 +13062,8 @@
         </p:nvSpPr>
         <p:spPr>
           <a:xfrm>
-            <a:off x="1143000" y="4355338"/>
-            <a:ext cx="10729862" cy="728472"/>
+            <a:off x="1143000" y="4257548"/>
+            <a:ext cx="10729862" cy="695960"/>
           </a:xfrm>
           <a:prstGeom prst="rect">
             <a:avLst/>
@@ -13078,11 +13078,11 @@
           <a:p>
             <a:pPr algn="l">
               <a:lnSpc>
-                <a:spcPts val="2688"/>
+                <a:spcPts val="2560"/>
               </a:lnSpc>
             </a:pPr>
             <a:r>
-              <a:rPr sz="2100" b="1">
+              <a:rPr sz="2000" b="1">
                 <a:solidFill>
                   <a:srgbClr val="1B2A4A"/>
                 </a:solidFill>
@@ -13091,23 +13091,23 @@
               <a:t>Daraja nomini chiqarish.: </a:t>
             </a:r>
             <a:r>
-              <a:rPr sz="2100" b="0">
+              <a:rPr sz="2000" b="0">
                 <a:solidFill>
                   <a:srgbClr val="1B2A4A"/>
                 </a:solidFill>
                 <a:latin typeface="Segoe UI"/>
               </a:rPr>
-              <a:t>G2 katakka =IF(E2&gt;=6;"Yuqori";IF(E2&gt;=3;"O‘rta";"Past"))</a:t>
+              <a:t>G2 katakka =ЕСЛИ(E2&gt;=6;"Yuqori";ЕСЛИ(E2&gt;=3;"O‘rta";"Past"))</a:t>
             </a:r>
             <a:br/>
             <a:r>
-              <a:rPr sz="2100" b="0">
+              <a:rPr sz="2000" b="0">
                 <a:solidFill>
                   <a:srgbClr val="1B2A4A"/>
                 </a:solidFill>
                 <a:latin typeface="Segoe UI"/>
               </a:rPr>
-              <a:t>formulasini yozing.</a:t>
+              <a:t>formulasini yozing (ingliz tilidagi Excel’da ЕСЛИ o‘rniga IF).</a:t>
             </a:r>
           </a:p>
         </p:txBody>
@@ -13120,7 +13120,7 @@
         </p:nvSpPr>
         <p:spPr>
           <a:xfrm rot="2700000">
-            <a:off x="841161" y="5294797"/>
+            <a:off x="841161" y="5156621"/>
             <a:ext cx="109901" cy="109901"/>
           </a:xfrm>
           <a:prstGeom prst="rect">
@@ -13164,8 +13164,8 @@
         </p:nvSpPr>
         <p:spPr>
           <a:xfrm>
-            <a:off x="1143000" y="5184394"/>
-            <a:ext cx="10729862" cy="728472"/>
+            <a:off x="1143000" y="5054092"/>
+            <a:ext cx="10729862" cy="695960"/>
           </a:xfrm>
           <a:prstGeom prst="rect">
             <a:avLst/>
@@ -13180,11 +13180,11 @@
           <a:p>
             <a:pPr algn="l">
               <a:lnSpc>
-                <a:spcPts val="2688"/>
+                <a:spcPts val="2560"/>
               </a:lnSpc>
             </a:pPr>
             <a:r>
-              <a:rPr sz="2100" b="1">
+              <a:rPr sz="2000" b="1">
                 <a:solidFill>
                   <a:srgbClr val="1B2A4A"/>
                 </a:solidFill>
@@ -13193,7 +13193,7 @@
               <a:t>Shartli formatlash.: </a:t>
             </a:r>
             <a:r>
-              <a:rPr sz="2100" b="0">
+              <a:rPr sz="2000" b="0">
                 <a:solidFill>
                   <a:srgbClr val="1B2A4A"/>
                 </a:solidFill>
@@ -13203,7 +13203,7 @@
             </a:r>
             <a:br/>
             <a:r>
-              <a:rPr sz="2100" b="0">
+              <a:rPr sz="2000" b="0">
                 <a:solidFill>
                   <a:srgbClr val="1B2A4A"/>
                 </a:solidFill>

</xml_diff>